<commit_message>
Fix PPT formatting: remove trash bright-orange/yellow headings; apply professional navy/slate/gold palette with Calibri typography
</commit_message>
<xml_diff>
--- a/jev-trading-plan.pptx
+++ b/jev-trading-plan.pptx
@@ -312,7 +312,7 @@
 </file>
 
 <file path=ppt/slides/slide1.xml><?xml version="1.0" encoding="utf-8"?>
-<p:sld xmlns:p="http://schemas.openxmlformats.org/presentationml/2006/main">
+<p:sld xmlns:a="http://schemas.openxmlformats.org/drawingml/2006/main" xmlns:p="http://schemas.openxmlformats.org/presentationml/2006/main">
   <p:cSld>
     <p:spTree>
       <p:nvGrpSpPr>
@@ -335,6 +335,9 @@
           <a:prstGeom xmlns:a="http://schemas.openxmlformats.org/drawingml/2006/main" prst="rect">
             <a:avLst/>
           </a:prstGeom>
+          <a:solidFill>
+            <a:srgbClr val="1B2838"/>
+          </a:solidFill>
         </p:spPr>
         <p:txBody>
           <a:bodyPr xmlns:a="http://schemas.openxmlformats.org/drawingml/2006/main"/>
@@ -343,8 +346,10 @@
             <a:r>
               <a:rPr lang="en-US" sz="2800" b="1">
                 <a:solidFill>
-                  <a:srgbClr val="1F4E79"/>
-                </a:solidFill>
+                  <a:srgbClr val="FFFFFF"/>
+                </a:solidFill>
+                <a:latin typeface="Calibri"/>
+                <a:ea typeface="Calibri"/>
               </a:rPr>
               <a:t>JEV-TRADING — PROPOSED PROJECT PLAN</a:t>
             </a:r>
@@ -353,8 +358,10 @@
             <a:r>
               <a:rPr lang="en-US" sz="2800" b="1">
                 <a:solidFill>
-                  <a:srgbClr val="1F4E79"/>
-                </a:solidFill>
+                  <a:srgbClr val="FFFFFF"/>
+                </a:solidFill>
+                <a:latin typeface="Calibri"/>
+                <a:ea typeface="Calibri"/>
               </a:rPr>
               <a:t>Extend MVP to P8 / Shadow Live | 2026-09-23</a:t>
             </a:r>
@@ -375,19 +382,34 @@
           <a:prstGeom xmlns:a="http://schemas.openxmlformats.org/drawingml/2006/main" prst="rect">
             <a:avLst/>
           </a:prstGeom>
-        </p:spPr>
-        <p:txBody>
-          <a:bodyPr xmlns:a="http://schemas.openxmlformats.org/drawingml/2006/main"/>
-          <a:lstStyle xmlns:a="http://schemas.openxmlformats.org/drawingml/2006/main"/>
-          <a:p xmlns:a="http://schemas.openxmlformats.org/drawingml/2006/main">
-            <a:r>
-              <a:rPr lang="en-US" sz="1400"/>
+          <a:solidFill>
+            <a:srgbClr val="1B2838"/>
+          </a:solidFill>
+        </p:spPr>
+        <p:txBody>
+          <a:bodyPr xmlns:a="http://schemas.openxmlformats.org/drawingml/2006/main"/>
+          <a:lstStyle xmlns:a="http://schemas.openxmlformats.org/drawingml/2006/main"/>
+          <a:p xmlns:a="http://schemas.openxmlformats.org/drawingml/2006/main">
+            <a:r>
+              <a:rPr lang="en-US" sz="1400">
+                <a:solidFill>
+                  <a:srgbClr val="D0D0D0"/>
+                </a:solidFill>
+                <a:latin typeface="Calibri"/>
+                <a:ea typeface="Calibri"/>
+              </a:rPr>
               <a:t>Scope: P7 iterate (threshold grid, cost-aware policy, down-model) → P8 shadow validation → Tiny-live proposal.</a:t>
             </a:r>
           </a:p>
           <a:p xmlns:a="http://schemas.openxmlformats.org/drawingml/2006/main">
             <a:r>
-              <a:rPr lang="en-US" sz="1400"/>
+              <a:rPr lang="en-US" sz="1400">
+                <a:solidFill>
+                  <a:srgbClr val="D0D0D0"/>
+                </a:solidFill>
+                <a:latin typeface="Calibri"/>
+                <a:ea typeface="Calibri"/>
+              </a:rPr>
               <a:t>Source: workspace README / IMPLEMENTATION_PLAN / docs / contracts / execution / backtest / data / scripts</a:t>
             </a:r>
           </a:p>
@@ -399,7 +421,7 @@
 </file>
 
 <file path=ppt/slides/slide10.xml><?xml version="1.0" encoding="utf-8"?>
-<p:sld xmlns:p="http://schemas.openxmlformats.org/presentationml/2006/main">
+<p:sld xmlns:a="http://schemas.openxmlformats.org/drawingml/2006/main" xmlns:p="http://schemas.openxmlformats.org/presentationml/2006/main">
   <p:cSld>
     <p:spTree>
       <p:nvGrpSpPr>
@@ -422,16 +444,21 @@
           <a:prstGeom xmlns:a="http://schemas.openxmlformats.org/drawingml/2006/main" prst="rect">
             <a:avLst/>
           </a:prstGeom>
-        </p:spPr>
-        <p:txBody>
-          <a:bodyPr xmlns:a="http://schemas.openxmlformats.org/drawingml/2006/main"/>
-          <a:lstStyle xmlns:a="http://schemas.openxmlformats.org/drawingml/2006/main"/>
-          <a:p xmlns:a="http://schemas.openxmlformats.org/drawingml/2006/main">
-            <a:r>
-              <a:rPr lang="en-US" sz="2400" b="1">
-                <a:solidFill>
-                  <a:srgbClr val="FFC000"/>
-                </a:solidFill>
+          <a:solidFill>
+            <a:srgbClr val="F4F5F7"/>
+          </a:solidFill>
+        </p:spPr>
+        <p:txBody>
+          <a:bodyPr xmlns:a="http://schemas.openxmlformats.org/drawingml/2006/main"/>
+          <a:lstStyle xmlns:a="http://schemas.openxmlformats.org/drawingml/2006/main"/>
+          <a:p xmlns:a="http://schemas.openxmlformats.org/drawingml/2006/main">
+            <a:r>
+              <a:rPr lang="en-US" sz="2600" b="1">
+                <a:solidFill>
+                  <a:srgbClr val="C5A065"/>
+                </a:solidFill>
+                <a:latin typeface="Calibri"/>
+                <a:ea typeface="Calibri"/>
               </a:rPr>
               <a:t>CONCLUSIONS &amp; NEXT STEPS</a:t>
             </a:r>
@@ -452,37 +479,70 @@
           <a:prstGeom xmlns:a="http://schemas.openxmlformats.org/drawingml/2006/main" prst="rect">
             <a:avLst/>
           </a:prstGeom>
-        </p:spPr>
-        <p:txBody>
-          <a:bodyPr xmlns:a="http://schemas.openxmlformats.org/drawingml/2006/main"/>
-          <a:lstStyle xmlns:a="http://schemas.openxmlformats.org/drawingml/2006/main"/>
-          <a:p xmlns:a="http://schemas.openxmlformats.org/drawingml/2006/main">
-            <a:r>
-              <a:rPr lang="en-US" sz="1100"/>
+          <a:solidFill>
+            <a:srgbClr val="FFFFFF"/>
+          </a:solidFill>
+        </p:spPr>
+        <p:txBody>
+          <a:bodyPr xmlns:a="http://schemas.openxmlformats.org/drawingml/2006/main"/>
+          <a:lstStyle xmlns:a="http://schemas.openxmlformats.org/drawingml/2006/main"/>
+          <a:p xmlns:a="http://schemas.openxmlformats.org/drawingml/2006/main">
+            <a:r>
+              <a:rPr lang="en-US" sz="1100">
+                <a:solidFill>
+                  <a:srgbClr val="333333"/>
+                </a:solidFill>
+                <a:latin typeface="Calibri"/>
+                <a:ea typeface="Calibri"/>
+              </a:rPr>
               <a:t>✅ Engineering complete (P0–P6); shadow pipeline validated (P8.1)</a:t>
             </a:r>
           </a:p>
           <a:p xmlns:a="http://schemas.openxmlformats.org/drawingml/2006/main">
             <a:r>
-              <a:rPr lang="en-US" sz="1100"/>
+              <a:rPr lang="en-US" sz="1100">
+                <a:solidFill>
+                  <a:srgbClr val="333333"/>
+                </a:solidFill>
+                <a:latin typeface="Calibri"/>
+                <a:ea typeface="Calibri"/>
+              </a:rPr>
               <a:t>❌ Trading edge does NOT survive current cost structure (P7 FAIL) — this is a successful experiment (no false promotion)</a:t>
             </a:r>
           </a:p>
           <a:p xmlns:a="http://schemas.openxmlformats.org/drawingml/2006/main">
             <a:r>
-              <a:rPr lang="en-US" sz="1100"/>
+              <a:rPr lang="en-US" sz="1100">
+                <a:solidFill>
+                  <a:srgbClr val="333333"/>
+                </a:solidFill>
+                <a:latin typeface="Calibri"/>
+                <a:ea typeface="Calibri"/>
+              </a:rPr>
               <a:t>➡ Next: Iterate P7 with lower turnover / cost-aware sizing / down-model; re-run hostile 2–3× gate; confirm net positive</a:t>
             </a:r>
           </a:p>
           <a:p xmlns:a="http://schemas.openxmlformats.org/drawingml/2006/main">
             <a:r>
-              <a:rPr lang="en-US" sz="1100"/>
+              <a:rPr lang="en-US" sz="1100">
+                <a:solidFill>
+                  <a:srgbClr val="333333"/>
+                </a:solidFill>
+                <a:latin typeface="Calibri"/>
+                <a:ea typeface="Calibri"/>
+              </a:rPr>
               <a:t>➡ Only then: Promote to P8 live paper → tiny-live → proposal / investment / compliance review</a:t>
             </a:r>
           </a:p>
           <a:p xmlns:a="http://schemas.openxmlformats.org/drawingml/2006/main">
             <a:r>
-              <a:rPr lang="en-US" sz="1100"/>
+              <a:rPr lang="en-US" sz="1100">
+                <a:solidFill>
+                  <a:srgbClr val="333333"/>
+                </a:solidFill>
+                <a:latin typeface="Calibri"/>
+                <a:ea typeface="Calibri"/>
+              </a:rPr>
               <a:t>Deliverables: PROPOSED_PLAN.md | jev-trading-plan.xlsx (5 sheets) | jev-trading-plan.pptx (10 slides) — all built via officecli v1.0.151 + monid research</a:t>
             </a:r>
           </a:p>
@@ -494,7 +554,7 @@
 </file>
 
 <file path=ppt/slides/slide2.xml><?xml version="1.0" encoding="utf-8"?>
-<p:sld xmlns:p="http://schemas.openxmlformats.org/presentationml/2006/main">
+<p:sld xmlns:a="http://schemas.openxmlformats.org/drawingml/2006/main" xmlns:p="http://schemas.openxmlformats.org/presentationml/2006/main">
   <p:cSld>
     <p:spTree>
       <p:nvGrpSpPr>
@@ -517,16 +577,21 @@
           <a:prstGeom xmlns:a="http://schemas.openxmlformats.org/drawingml/2006/main" prst="rect">
             <a:avLst/>
           </a:prstGeom>
-        </p:spPr>
-        <p:txBody>
-          <a:bodyPr xmlns:a="http://schemas.openxmlformats.org/drawingml/2006/main"/>
-          <a:lstStyle xmlns:a="http://schemas.openxmlformats.org/drawingml/2006/main"/>
-          <a:p xmlns:a="http://schemas.openxmlformats.org/drawingml/2006/main">
-            <a:r>
-              <a:rPr lang="en-US" sz="2400" b="1">
-                <a:solidFill>
-                  <a:srgbClr val="FFC000"/>
-                </a:solidFill>
+          <a:solidFill>
+            <a:srgbClr val="F4F5F7"/>
+          </a:solidFill>
+        </p:spPr>
+        <p:txBody>
+          <a:bodyPr xmlns:a="http://schemas.openxmlformats.org/drawingml/2006/main"/>
+          <a:lstStyle xmlns:a="http://schemas.openxmlformats.org/drawingml/2006/main"/>
+          <a:p xmlns:a="http://schemas.openxmlformats.org/drawingml/2006/main">
+            <a:r>
+              <a:rPr lang="en-US" sz="2600" b="1">
+                <a:solidFill>
+                  <a:srgbClr val="C5A065"/>
+                </a:solidFill>
+                <a:latin typeface="Calibri"/>
+                <a:ea typeface="Calibri"/>
               </a:rPr>
               <a:t>PROJECT OVERVIEW &amp; CURRENT STATUS</a:t>
             </a:r>
@@ -547,31 +612,58 @@
           <a:prstGeom xmlns:a="http://schemas.openxmlformats.org/drawingml/2006/main" prst="rect">
             <a:avLst/>
           </a:prstGeom>
-        </p:spPr>
-        <p:txBody>
-          <a:bodyPr xmlns:a="http://schemas.openxmlformats.org/drawingml/2006/main"/>
-          <a:lstStyle xmlns:a="http://schemas.openxmlformats.org/drawingml/2006/main"/>
-          <a:p xmlns:a="http://schemas.openxmlformats.org/drawingml/2006/main">
-            <a:r>
-              <a:rPr lang="en-US" sz="1200"/>
+          <a:solidFill>
+            <a:srgbClr val="FFFFFF"/>
+          </a:solidFill>
+        </p:spPr>
+        <p:txBody>
+          <a:bodyPr xmlns:a="http://schemas.openxmlformats.org/drawingml/2006/main"/>
+          <a:lstStyle xmlns:a="http://schemas.openxmlformats.org/drawingml/2006/main"/>
+          <a:p xmlns:a="http://schemas.openxmlformats.org/drawingml/2006/main">
+            <a:r>
+              <a:rPr lang="en-US" sz="1300">
+                <a:solidFill>
+                  <a:srgbClr val="333333"/>
+                </a:solidFill>
+                <a:latin typeface="Calibri"/>
+                <a:ea typeface="Calibri"/>
+              </a:rPr>
               <a:t>• Pipeline: Live feed → State (16 features) → Quant (LightGBM AUC 0.637, ECE 0.01) → Jev(mock) → Policy → Risk (absolute) → PaperExec → JSONL replay</a:t>
             </a:r>
           </a:p>
           <a:p xmlns:a="http://schemas.openxmlformats.org/drawingml/2006/main">
             <a:r>
-              <a:rPr lang="en-US" sz="1200"/>
+              <a:rPr lang="en-US" sz="1300">
+                <a:solidFill>
+                  <a:srgbClr val="333333"/>
+                </a:solidFill>
+                <a:latin typeface="Calibri"/>
+                <a:ea typeface="Calibri"/>
+              </a:rPr>
               <a:t>• Data: 2,629,440 1m BTCUSDT perp rows [2021–2026], contiguous, 0 dupes</a:t>
             </a:r>
           </a:p>
           <a:p xmlns:a="http://schemas.openxmlformats.org/drawingml/2006/main">
             <a:r>
-              <a:rPr lang="en-US" sz="1200"/>
+              <a:rPr lang="en-US" sz="1300">
+                <a:solidFill>
+                  <a:srgbClr val="333333"/>
+                </a:solidFill>
+                <a:latin typeface="Calibri"/>
+                <a:ea typeface="Calibri"/>
+              </a:rPr>
               <a:t>• P0–P6 ✅ | P7 FAIL (net −0.35% at p_up≥0.55; 2–3× fees deepen) | P8 shadow validated live (4 bars, 0 entries consistent, latency 634–1548ms)</a:t>
             </a:r>
           </a:p>
           <a:p xmlns:a="http://schemas.openxmlformats.org/drawingml/2006/main">
             <a:r>
-              <a:rPr lang="en-US" sz="1200"/>
+              <a:rPr lang="en-US" sz="1300">
+                <a:solidFill>
+                  <a:srgbClr val="333333"/>
+                </a:solidFill>
+                <a:latin typeface="Calibri"/>
+                <a:ea typeface="Calibri"/>
+              </a:rPr>
               <a:t>• Next: 4–7 weeks to iterate thresholds / validate / propose promotion</a:t>
             </a:r>
           </a:p>
@@ -583,7 +675,7 @@
 </file>
 
 <file path=ppt/slides/slide3.xml><?xml version="1.0" encoding="utf-8"?>
-<p:sld xmlns:p="http://schemas.openxmlformats.org/presentationml/2006/main">
+<p:sld xmlns:a="http://schemas.openxmlformats.org/drawingml/2006/main" xmlns:p="http://schemas.openxmlformats.org/presentationml/2006/main">
   <p:cSld>
     <p:spTree>
       <p:nvGrpSpPr>
@@ -606,16 +698,21 @@
           <a:prstGeom xmlns:a="http://schemas.openxmlformats.org/drawingml/2006/main" prst="rect">
             <a:avLst/>
           </a:prstGeom>
-        </p:spPr>
-        <p:txBody>
-          <a:bodyPr xmlns:a="http://schemas.openxmlformats.org/drawingml/2006/main"/>
-          <a:lstStyle xmlns:a="http://schemas.openxmlformats.org/drawingml/2006/main"/>
-          <a:p xmlns:a="http://schemas.openxmlformats.org/drawingml/2006/main">
-            <a:r>
-              <a:rPr lang="en-US" sz="2400" b="1">
-                <a:solidFill>
-                  <a:srgbClr val="FFC000"/>
-                </a:solidFill>
+          <a:solidFill>
+            <a:srgbClr val="F4F5F7"/>
+          </a:solidFill>
+        </p:spPr>
+        <p:txBody>
+          <a:bodyPr xmlns:a="http://schemas.openxmlformats.org/drawingml/2006/main"/>
+          <a:lstStyle xmlns:a="http://schemas.openxmlformats.org/drawingml/2006/main"/>
+          <a:p xmlns:a="http://schemas.openxmlformats.org/drawingml/2006/main">
+            <a:r>
+              <a:rPr lang="en-US" sz="2600" b="1">
+                <a:solidFill>
+                  <a:srgbClr val="C5A065"/>
+                </a:solidFill>
+                <a:latin typeface="Calibri"/>
+                <a:ea typeface="Calibri"/>
               </a:rPr>
               <a:t>ARCHITECTURE — 6-LAYER FAST LOOP</a:t>
             </a:r>
@@ -636,43 +733,82 @@
           <a:prstGeom xmlns:a="http://schemas.openxmlformats.org/drawingml/2006/main" prst="rect">
             <a:avLst/>
           </a:prstGeom>
-        </p:spPr>
-        <p:txBody>
-          <a:bodyPr xmlns:a="http://schemas.openxmlformats.org/drawingml/2006/main"/>
-          <a:lstStyle xmlns:a="http://schemas.openxmlformats.org/drawingml/2006/main"/>
-          <a:p xmlns:a="http://schemas.openxmlformats.org/drawingml/2006/main">
-            <a:r>
-              <a:rPr lang="en-US" sz="1100"/>
+          <a:solidFill>
+            <a:srgbClr val="FFFFFF"/>
+          </a:solidFill>
+        </p:spPr>
+        <p:txBody>
+          <a:bodyPr xmlns:a="http://schemas.openxmlformats.org/drawingml/2006/main"/>
+          <a:lstStyle xmlns:a="http://schemas.openxmlformats.org/drawingml/2006/main"/>
+          <a:p xmlns:a="http://schemas.openxmlformats.org/drawingml/2006/main">
+            <a:r>
+              <a:rPr lang="en-US" sz="1100">
+                <a:solidFill>
+                  <a:srgbClr val="333333"/>
+                </a:solidFill>
+                <a:latin typeface="Calibri"/>
+                <a:ea typeface="Calibri"/>
+              </a:rPr>
               <a:t>L1 Data Ingest (Binance REST 1200w/min + WS + Kalshi/Polymarket)</a:t>
             </a:r>
           </a:p>
           <a:p xmlns:a="http://schemas.openxmlformats.org/drawingml/2006/main">
             <a:r>
-              <a:rPr lang="en-US" sz="1100"/>
+              <a:rPr lang="en-US" sz="1100">
+                <a:solidFill>
+                  <a:srgbClr val="333333"/>
+                </a:solidFill>
+                <a:latin typeface="Calibri"/>
+                <a:ea typeface="Calibri"/>
+              </a:rPr>
               <a:t>L2 State Engine (backward-only 16 feats + build_state_dict)</a:t>
             </a:r>
           </a:p>
           <a:p xmlns:a="http://schemas.openxmlformats.org/drawingml/2006/main">
             <a:r>
-              <a:rPr lang="en-US" sz="1100"/>
+              <a:rPr lang="en-US" sz="1100">
+                <a:solidFill>
+                  <a:srgbClr val="333333"/>
+                </a:solidFill>
+                <a:latin typeface="Calibri"/>
+                <a:ea typeface="Calibri"/>
+              </a:rPr>
               <a:t>L3 Quant Engine (LightGBM; y_up_15 / y_dn_15; threshold 0.0014 frozen)</a:t>
             </a:r>
           </a:p>
           <a:p xmlns:a="http://schemas.openxmlformats.org/drawingml/2006/main">
             <a:r>
-              <a:rPr lang="en-US" sz="1100"/>
+              <a:rPr lang="en-US" sz="1100">
+                <a:solidFill>
+                  <a:srgbClr val="333333"/>
+                </a:solidFill>
+                <a:latin typeface="Calibri"/>
+                <a:ea typeface="Calibri"/>
+              </a:rPr>
               <a:t>L4 Jev / Mock Client (5 MVP yes/no; TypeSafe protocol; position-aware P7)</a:t>
             </a:r>
           </a:p>
           <a:p xmlns:a="http://schemas.openxmlformats.org/drawingml/2006/main">
             <a:r>
-              <a:rPr lang="en-US" sz="1100"/>
+              <a:rPr lang="en-US" sz="1100">
+                <a:solidFill>
+                  <a:srgbClr val="333333"/>
+                </a:solidFill>
+                <a:latin typeface="Calibri"/>
+                <a:ea typeface="Calibri"/>
+              </a:rPr>
               <a:t>L5 Policy + Risk (threshold policy + audit reasons; deterministic RiskKernel; halt/gate)</a:t>
             </a:r>
           </a:p>
           <a:p xmlns:a="http://schemas.openxmlformats.org/drawingml/2006/main">
             <a:r>
-              <a:rPr lang="en-US" sz="1100"/>
+              <a:rPr lang="en-US" sz="1100">
+                <a:solidFill>
+                  <a:srgbClr val="333333"/>
+                </a:solidFill>
+                <a:latin typeface="Calibri"/>
+                <a:ea typeface="Calibri"/>
+              </a:rPr>
               <a:t>L6 Paper Execution (PaperTrader; next-open; replayable JSONL; zero real money)</a:t>
             </a:r>
           </a:p>
@@ -684,7 +820,7 @@
 </file>
 
 <file path=ppt/slides/slide4.xml><?xml version="1.0" encoding="utf-8"?>
-<p:sld xmlns:p="http://schemas.openxmlformats.org/presentationml/2006/main">
+<p:sld xmlns:a="http://schemas.openxmlformats.org/drawingml/2006/main" xmlns:p="http://schemas.openxmlformats.org/presentationml/2006/main">
   <p:cSld>
     <p:spTree>
       <p:nvGrpSpPr>
@@ -707,16 +843,21 @@
           <a:prstGeom xmlns:a="http://schemas.openxmlformats.org/drawingml/2006/main" prst="rect">
             <a:avLst/>
           </a:prstGeom>
-        </p:spPr>
-        <p:txBody>
-          <a:bodyPr xmlns:a="http://schemas.openxmlformats.org/drawingml/2006/main"/>
-          <a:lstStyle xmlns:a="http://schemas.openxmlformats.org/drawingml/2006/main"/>
-          <a:p xmlns:a="http://schemas.openxmlformats.org/drawingml/2006/main">
-            <a:r>
-              <a:rPr lang="en-US" sz="2400" b="1">
-                <a:solidFill>
-                  <a:srgbClr val="FFC000"/>
-                </a:solidFill>
+          <a:solidFill>
+            <a:srgbClr val="F4F5F7"/>
+          </a:solidFill>
+        </p:spPr>
+        <p:txBody>
+          <a:bodyPr xmlns:a="http://schemas.openxmlformats.org/drawingml/2006/main"/>
+          <a:lstStyle xmlns:a="http://schemas.openxmlformats.org/drawingml/2006/main"/>
+          <a:p xmlns:a="http://schemas.openxmlformats.org/drawingml/2006/main">
+            <a:r>
+              <a:rPr lang="en-US" sz="2600" b="1">
+                <a:solidFill>
+                  <a:srgbClr val="C5A065"/>
+                </a:solidFill>
+                <a:latin typeface="Calibri"/>
+                <a:ea typeface="Calibri"/>
               </a:rPr>
               <a:t>TOOL RESEARCH — ML, DATA &amp; APIs (Monid + Specs + Cost)</a:t>
             </a:r>
@@ -737,43 +878,82 @@
           <a:prstGeom xmlns:a="http://schemas.openxmlformats.org/drawingml/2006/main" prst="rect">
             <a:avLst/>
           </a:prstGeom>
-        </p:spPr>
-        <p:txBody>
-          <a:bodyPr xmlns:a="http://schemas.openxmlformats.org/drawingml/2006/main"/>
-          <a:lstStyle xmlns:a="http://schemas.openxmlformats.org/drawingml/2006/main"/>
-          <a:p xmlns:a="http://schemas.openxmlformats.org/drawingml/2006/main">
-            <a:r>
-              <a:rPr lang="en-US" sz="1100"/>
+          <a:solidFill>
+            <a:srgbClr val="FFFFFF"/>
+          </a:solidFill>
+        </p:spPr>
+        <p:txBody>
+          <a:bodyPr xmlns:a="http://schemas.openxmlformats.org/drawingml/2006/main"/>
+          <a:lstStyle xmlns:a="http://schemas.openxmlformats.org/drawingml/2006/main"/>
+          <a:p xmlns:a="http://schemas.openxmlformats.org/drawingml/2006/main">
+            <a:r>
+              <a:rPr lang="en-US" sz="1100">
+                <a:solidFill>
+                  <a:srgbClr val="333333"/>
+                </a:solidFill>
+                <a:latin typeface="Calibri"/>
+                <a:ea typeface="Calibri"/>
+              </a:rPr>
               <a:t>LightGBM — MIT / Microsoft / AUC 0.637 / ECE 0.01 / CPU ~1–3min train / $0</a:t>
             </a:r>
           </a:p>
           <a:p xmlns:a="http://schemas.openxmlformats.org/drawingml/2006/main">
             <a:r>
-              <a:rPr lang="en-US" sz="1100"/>
+              <a:rPr lang="en-US" sz="1100">
+                <a:solidFill>
+                  <a:srgbClr val="333333"/>
+                </a:solidFill>
+                <a:latin typeface="Calibri"/>
+                <a:ea typeface="Calibri"/>
+              </a:rPr>
               <a:t>NumPy/Pandas — BSD / 2.6M rows / RAM 4–8GB / $0</a:t>
             </a:r>
           </a:p>
           <a:p xmlns:a="http://schemas.openxmlformats.org/drawingml/2006/main">
             <a:r>
-              <a:rPr lang="en-US" sz="1100"/>
+              <a:rPr lang="en-US" sz="1100">
+                <a:solidFill>
+                  <a:srgbClr val="333333"/>
+                </a:solidFill>
+                <a:latin typeface="Calibri"/>
+                <a:ea typeface="Calibri"/>
+              </a:rPr>
               <a:t>Binance REST — Free / 1200 weight/min / 1m klines / $0</a:t>
             </a:r>
           </a:p>
           <a:p xmlns:a="http://schemas.openxmlformats.org/drawingml/2006/main">
             <a:r>
-              <a:rPr lang="en-US" sz="1100"/>
+              <a:rPr lang="en-US" sz="1100">
+                <a:solidFill>
+                  <a:srgbClr val="333333"/>
+                </a:solidFill>
+                <a:latin typeface="Calibri"/>
+                <a:ea typeface="Calibri"/>
+              </a:rPr>
               <a:t>Binance WS — Free / real-time / ~5 conn/min / $0</a:t>
             </a:r>
           </a:p>
           <a:p xmlns:a="http://schemas.openxmlformats.org/drawingml/2006/main">
             <a:r>
-              <a:rPr lang="en-US" sz="1100"/>
+              <a:rPr lang="en-US" sz="1100">
+                <a:solidFill>
+                  <a:srgbClr val="333333"/>
+                </a:solidFill>
+                <a:latin typeface="Calibri"/>
+                <a:ea typeface="Calibri"/>
+              </a:rPr>
               <a:t>Polymarket/Kalshi — Free read / PM_COLUMNS / warn-and-continue / $0</a:t>
             </a:r>
           </a:p>
           <a:p xmlns:a="http://schemas.openxmlformats.org/drawingml/2006/main">
             <a:r>
-              <a:rPr lang="en-US" sz="1100"/>
+              <a:rPr lang="en-US" sz="1100">
+                <a:solidFill>
+                  <a:srgbClr val="333333"/>
+                </a:solidFill>
+                <a:latin typeface="Calibri"/>
+                <a:ea typeface="Calibri"/>
+              </a:rPr>
               <a:t>Scikit-learn — BSD / baselines A–E / $0</a:t>
             </a:r>
           </a:p>
@@ -785,7 +965,7 @@
 </file>
 
 <file path=ppt/slides/slide5.xml><?xml version="1.0" encoding="utf-8"?>
-<p:sld xmlns:p="http://schemas.openxmlformats.org/presentationml/2006/main">
+<p:sld xmlns:a="http://schemas.openxmlformats.org/drawingml/2006/main" xmlns:p="http://schemas.openxmlformats.org/presentationml/2006/main">
   <p:cSld>
     <p:spTree>
       <p:nvGrpSpPr>
@@ -808,16 +988,21 @@
           <a:prstGeom xmlns:a="http://schemas.openxmlformats.org/drawingml/2006/main" prst="rect">
             <a:avLst/>
           </a:prstGeom>
-        </p:spPr>
-        <p:txBody>
-          <a:bodyPr xmlns:a="http://schemas.openxmlformats.org/drawingml/2006/main"/>
-          <a:lstStyle xmlns:a="http://schemas.openxmlformats.org/drawingml/2006/main"/>
-          <a:p xmlns:a="http://schemas.openxmlformats.org/drawingml/2006/main">
-            <a:r>
-              <a:rPr lang="en-US" sz="2400" b="1">
-                <a:solidFill>
-                  <a:srgbClr val="FFC000"/>
-                </a:solidFill>
+          <a:solidFill>
+            <a:srgbClr val="F4F5F7"/>
+          </a:solidFill>
+        </p:spPr>
+        <p:txBody>
+          <a:bodyPr xmlns:a="http://schemas.openxmlformats.org/drawingml/2006/main"/>
+          <a:lstStyle xmlns:a="http://schemas.openxmlformats.org/drawingml/2006/main"/>
+          <a:p xmlns:a="http://schemas.openxmlformats.org/drawingml/2006/main">
+            <a:r>
+              <a:rPr lang="en-US" sz="2600" b="1">
+                <a:solidFill>
+                  <a:srgbClr val="C5A065"/>
+                </a:solidFill>
+                <a:latin typeface="Calibri"/>
+                <a:ea typeface="Calibri"/>
               </a:rPr>
               <a:t>TOOL RESEARCH — UI, EXECUTION &amp; OFFICE CLI</a:t>
             </a:r>
@@ -838,43 +1023,82 @@
           <a:prstGeom xmlns:a="http://schemas.openxmlformats.org/drawingml/2006/main" prst="rect">
             <a:avLst/>
           </a:prstGeom>
-        </p:spPr>
-        <p:txBody>
-          <a:bodyPr xmlns:a="http://schemas.openxmlformats.org/drawingml/2006/main"/>
-          <a:lstStyle xmlns:a="http://schemas.openxmlformats.org/drawingml/2006/main"/>
-          <a:p xmlns:a="http://schemas.openxmlformats.org/drawingml/2006/main">
-            <a:r>
-              <a:rPr lang="en-US" sz="1100"/>
+          <a:solidFill>
+            <a:srgbClr val="FFFFFF"/>
+          </a:solidFill>
+        </p:spPr>
+        <p:txBody>
+          <a:bodyPr xmlns:a="http://schemas.openxmlformats.org/drawingml/2006/main"/>
+          <a:lstStyle xmlns:a="http://schemas.openxmlformats.org/drawingml/2006/main"/>
+          <a:p xmlns:a="http://schemas.openxmlformats.org/drawingml/2006/main">
+            <a:r>
+              <a:rPr lang="en-US" sz="1100">
+                <a:solidFill>
+                  <a:srgbClr val="333333"/>
+                </a:solidFill>
+                <a:latin typeface="Calibri"/>
+                <a:ea typeface="Calibri"/>
+              </a:rPr>
               <a:t>Streamlit — Apache 2 / dashboard / free tier + ~$5/mo paid / $0 local</a:t>
             </a:r>
           </a:p>
           <a:p xmlns:a="http://schemas.openxmlformats.org/drawingml/2006/main">
             <a:r>
-              <a:rPr lang="en-US" sz="1100"/>
+              <a:rPr lang="en-US" sz="1100">
+                <a:solidFill>
+                  <a:srgbClr val="333333"/>
+                </a:solidFill>
+                <a:latin typeface="Calibri"/>
+                <a:ea typeface="Calibri"/>
+              </a:rPr>
               <a:t>PaperTrader (execution/) — Project / zero real money / JSONL replay / 634–1548ms/bar / $0</a:t>
             </a:r>
           </a:p>
           <a:p xmlns:a="http://schemas.openxmlformats.org/drawingml/2006/main">
             <a:r>
-              <a:rPr lang="en-US" sz="1100"/>
+              <a:rPr lang="en-US" sz="1100">
+                <a:solidFill>
+                  <a:srgbClr val="333333"/>
+                </a:solidFill>
+                <a:latin typeface="Calibri"/>
+                <a:ea typeface="Calibri"/>
+              </a:rPr>
               <a:t>Backtest Simulator — Project / BAR→STATE→QUANT→JEV→POLICY→RISK→ORDER / CPU hours / $0</a:t>
             </a:r>
           </a:p>
           <a:p xmlns:a="http://schemas.openxmlformats.org/drawingml/2006/main">
             <a:r>
-              <a:rPr lang="en-US" sz="1100"/>
+              <a:rPr lang="en-US" sz="1100">
+                <a:solidFill>
+                  <a:srgbClr val="333333"/>
+                </a:solidFill>
+                <a:latin typeface="Calibri"/>
+                <a:ea typeface="Calibri"/>
+              </a:rPr>
               <a:t>officecli v1.0.151 — CLI / .xlsx/.pptx create/edit/batch / $0 (this deliverable)</a:t>
             </a:r>
           </a:p>
           <a:p xmlns:a="http://schemas.openxmlformats.org/drawingml/2006/main">
             <a:r>
-              <a:rPr lang="en-US" sz="1100"/>
+              <a:rPr lang="en-US" sz="1100">
+                <a:solidFill>
+                  <a:srgbClr val="333333"/>
+                </a:solidFill>
+                <a:latin typeface="Calibri"/>
+                <a:ea typeface="Calibri"/>
+              </a:rPr>
               <a:t>Python 3.12 / PyArrow / requests — PSF/Apache / $0</a:t>
             </a:r>
           </a:p>
           <a:p xmlns:a="http://schemas.openxmlformats.org/drawingml/2006/main">
             <a:r>
-              <a:rPr lang="en-US" sz="1100"/>
+              <a:rPr lang="en-US" sz="1100">
+                <a:solidFill>
+                  <a:srgbClr val="333333"/>
+                </a:solidFill>
+                <a:latin typeface="Calibri"/>
+                <a:ea typeface="Calibri"/>
+              </a:rPr>
               <a:t>Monitoring: Prometheus/Grafana self-host ~$15/mo or Datadog ~$30/mo</a:t>
             </a:r>
           </a:p>
@@ -886,7 +1110,7 @@
 </file>
 
 <file path=ppt/slides/slide6.xml><?xml version="1.0" encoding="utf-8"?>
-<p:sld xmlns:p="http://schemas.openxmlformats.org/presentationml/2006/main">
+<p:sld xmlns:a="http://schemas.openxmlformats.org/drawingml/2006/main" xmlns:p="http://schemas.openxmlformats.org/presentationml/2006/main">
   <p:cSld>
     <p:spTree>
       <p:nvGrpSpPr>
@@ -909,16 +1133,21 @@
           <a:prstGeom xmlns:a="http://schemas.openxmlformats.org/drawingml/2006/main" prst="rect">
             <a:avLst/>
           </a:prstGeom>
-        </p:spPr>
-        <p:txBody>
-          <a:bodyPr xmlns:a="http://schemas.openxmlformats.org/drawingml/2006/main"/>
-          <a:lstStyle xmlns:a="http://schemas.openxmlformats.org/drawingml/2006/main"/>
-          <a:p xmlns:a="http://schemas.openxmlformats.org/drawingml/2006/main">
-            <a:r>
-              <a:rPr lang="en-US" sz="2400" b="1">
-                <a:solidFill>
-                  <a:srgbClr val="FFC000"/>
-                </a:solidFill>
+          <a:solidFill>
+            <a:srgbClr val="F4F5F7"/>
+          </a:solidFill>
+        </p:spPr>
+        <p:txBody>
+          <a:bodyPr xmlns:a="http://schemas.openxmlformats.org/drawingml/2006/main"/>
+          <a:lstStyle xmlns:a="http://schemas.openxmlformats.org/drawingml/2006/main"/>
+          <a:p xmlns:a="http://schemas.openxmlformats.org/drawingml/2006/main">
+            <a:r>
+              <a:rPr lang="en-US" sz="2600" b="1">
+                <a:solidFill>
+                  <a:srgbClr val="C5A065"/>
+                </a:solidFill>
+                <a:latin typeface="Calibri"/>
+                <a:ea typeface="Calibri"/>
               </a:rPr>
               <a:t>RESOURCES &amp; HARDWARE RECOMMENDATIONS</a:t>
             </a:r>
@@ -939,49 +1168,94 @@
           <a:prstGeom xmlns:a="http://schemas.openxmlformats.org/drawingml/2006/main" prst="rect">
             <a:avLst/>
           </a:prstGeom>
-        </p:spPr>
-        <p:txBody>
-          <a:bodyPr xmlns:a="http://schemas.openxmlformats.org/drawingml/2006/main"/>
-          <a:lstStyle xmlns:a="http://schemas.openxmlformats.org/drawingml/2006/main"/>
-          <a:p xmlns:a="http://schemas.openxmlformats.org/drawingml/2006/main">
-            <a:r>
-              <a:rPr lang="en-US" sz="1100"/>
+          <a:solidFill>
+            <a:srgbClr val="FFFFFF"/>
+          </a:solidFill>
+        </p:spPr>
+        <p:txBody>
+          <a:bodyPr xmlns:a="http://schemas.openxmlformats.org/drawingml/2006/main"/>
+          <a:lstStyle xmlns:a="http://schemas.openxmlformats.org/drawingml/2006/main"/>
+          <a:p xmlns:a="http://schemas.openxmlformats.org/drawingml/2006/main">
+            <a:r>
+              <a:rPr lang="en-US" sz="1100">
+                <a:solidFill>
+                  <a:srgbClr val="333333"/>
+                </a:solidFill>
+                <a:latin typeface="Calibri"/>
+                <a:ea typeface="Calibri"/>
+              </a:rPr>
               <a:t>Dev / Shadow: 8-core CPU / 32GB RAM / 1TB NVMe (existing) / $2,000 one-time</a:t>
             </a:r>
           </a:p>
           <a:p xmlns:a="http://schemas.openxmlformats.org/drawingml/2006/main">
             <a:r>
-              <a:rPr lang="en-US" sz="1100"/>
+              <a:rPr lang="en-US" sz="1100">
+                <a:solidFill>
+                  <a:srgbClr val="333333"/>
+                </a:solidFill>
+                <a:latin typeface="Calibri"/>
+                <a:ea typeface="Calibri"/>
+              </a:rPr>
               <a:t>Shadow Server: AWS t3.medium (2 vCPU / 4GB) / ~$30/mo / us-east-1</a:t>
             </a:r>
           </a:p>
           <a:p xmlns:a="http://schemas.openxmlformats.org/drawingml/2006/main">
             <a:r>
-              <a:rPr lang="en-US" sz="1100"/>
+              <a:rPr lang="en-US" sz="1100">
+                <a:solidFill>
+                  <a:srgbClr val="333333"/>
+                </a:solidFill>
+                <a:latin typeface="Calibri"/>
+                <a:ea typeface="Calibri"/>
+              </a:rPr>
               <a:t>Tiny-Live (post-P7): AWS c6i.large (2 vCPU / 4GB) / ~$62/mo / 100GB SSD</a:t>
             </a:r>
           </a:p>
           <a:p xmlns:a="http://schemas.openxmlformats.org/drawingml/2006/main">
             <a:r>
-              <a:rPr lang="en-US" sz="1100"/>
+              <a:rPr lang="en-US" sz="1100">
+                <a:solidFill>
+                  <a:srgbClr val="333333"/>
+                </a:solidFill>
+                <a:latin typeface="Calibri"/>
+                <a:ea typeface="Calibri"/>
+              </a:rPr>
               <a:t>Storage: Local 1TB + S3 500GB backup / ~$11/mo</a:t>
             </a:r>
           </a:p>
           <a:p xmlns:a="http://schemas.openxmlformats.org/drawingml/2006/main">
             <a:r>
-              <a:rPr lang="en-US" sz="1100"/>
+              <a:rPr lang="en-US" sz="1100">
+                <a:solidFill>
+                  <a:srgbClr val="333333"/>
+                </a:solidFill>
+                <a:latin typeface="Calibri"/>
+                <a:ea typeface="Calibri"/>
+              </a:rPr>
               <a:t>Network: Broadband + static IP / VPN / ~$10/mo</a:t>
             </a:r>
           </a:p>
           <a:p xmlns:a="http://schemas.openxmlformats.org/drawingml/2006/main">
             <a:r>
-              <a:rPr lang="en-US" sz="1100"/>
+              <a:rPr lang="en-US" sz="1100">
+                <a:solidFill>
+                  <a:srgbClr val="333333"/>
+                </a:solidFill>
+                <a:latin typeface="Calibri"/>
+                <a:ea typeface="Calibri"/>
+              </a:rPr>
               <a:t>GPU (deferred): NVIDIA T4 / A10 / ~$250–600/mo ONLY if P7 justifies deep model</a:t>
             </a:r>
           </a:p>
           <a:p xmlns:a="http://schemas.openxmlformats.org/drawingml/2006/main">
             <a:r>
-              <a:rPr lang="en-US" sz="1100"/>
+              <a:rPr lang="en-US" sz="1100">
+                <a:solidFill>
+                  <a:srgbClr val="333333"/>
+                </a:solidFill>
+                <a:latin typeface="Calibri"/>
+                <a:ea typeface="Calibri"/>
+              </a:rPr>
               <a:t>Total Shadow: ~$65–100/mo | Tiny-Live: ~$120–180/mo</a:t>
             </a:r>
           </a:p>
@@ -993,7 +1267,7 @@
 </file>
 
 <file path=ppt/slides/slide7.xml><?xml version="1.0" encoding="utf-8"?>
-<p:sld xmlns:p="http://schemas.openxmlformats.org/presentationml/2006/main">
+<p:sld xmlns:a="http://schemas.openxmlformats.org/drawingml/2006/main" xmlns:p="http://schemas.openxmlformats.org/presentationml/2006/main">
   <p:cSld>
     <p:spTree>
       <p:nvGrpSpPr>
@@ -1016,16 +1290,21 @@
           <a:prstGeom xmlns:a="http://schemas.openxmlformats.org/drawingml/2006/main" prst="rect">
             <a:avLst/>
           </a:prstGeom>
-        </p:spPr>
-        <p:txBody>
-          <a:bodyPr xmlns:a="http://schemas.openxmlformats.org/drawingml/2006/main"/>
-          <a:lstStyle xmlns:a="http://schemas.openxmlformats.org/drawingml/2006/main"/>
-          <a:p xmlns:a="http://schemas.openxmlformats.org/drawingml/2006/main">
-            <a:r>
-              <a:rPr lang="en-US" sz="2400" b="1">
-                <a:solidFill>
-                  <a:srgbClr val="FFC000"/>
-                </a:solidFill>
+          <a:solidFill>
+            <a:srgbClr val="F4F5F7"/>
+          </a:solidFill>
+        </p:spPr>
+        <p:txBody>
+          <a:bodyPr xmlns:a="http://schemas.openxmlformats.org/drawingml/2006/main"/>
+          <a:lstStyle xmlns:a="http://schemas.openxmlformats.org/drawingml/2006/main"/>
+          <a:p xmlns:a="http://schemas.openxmlformats.org/drawingml/2006/main">
+            <a:r>
+              <a:rPr lang="en-US" sz="2600" b="1">
+                <a:solidFill>
+                  <a:srgbClr val="C5A065"/>
+                </a:solidFill>
+                <a:latin typeface="Calibri"/>
+                <a:ea typeface="Calibri"/>
               </a:rPr>
               <a:t>RUNNING COSTS — MONTHLY BREAKDOWN</a:t>
             </a:r>
@@ -1046,43 +1325,82 @@
           <a:prstGeom xmlns:a="http://schemas.openxmlformats.org/drawingml/2006/main" prst="rect">
             <a:avLst/>
           </a:prstGeom>
-        </p:spPr>
-        <p:txBody>
-          <a:bodyPr xmlns:a="http://schemas.openxmlformats.org/drawingml/2006/main"/>
-          <a:lstStyle xmlns:a="http://schemas.openxmlformats.org/drawingml/2006/main"/>
-          <a:p xmlns:a="http://schemas.openxmlformats.org/drawingml/2006/main">
-            <a:r>
-              <a:rPr lang="en-US" sz="1100"/>
+          <a:solidFill>
+            <a:srgbClr val="FFFFFF"/>
+          </a:solidFill>
+        </p:spPr>
+        <p:txBody>
+          <a:bodyPr xmlns:a="http://schemas.openxmlformats.org/drawingml/2006/main"/>
+          <a:lstStyle xmlns:a="http://schemas.openxmlformats.org/drawingml/2006/main"/>
+          <a:p xmlns:a="http://schemas.openxmlformats.org/drawingml/2006/main">
+            <a:r>
+              <a:rPr lang="en-US" sz="1100">
+                <a:solidFill>
+                  <a:srgbClr val="333333"/>
+                </a:solidFill>
+                <a:latin typeface="Calibri"/>
+                <a:ea typeface="Calibri"/>
+              </a:rPr>
               <a:t>Compute (t3.medium shadow): $30  |  Compute (c6i.large live): $62</a:t>
             </a:r>
           </a:p>
           <a:p xmlns:a="http://schemas.openxmlformats.org/drawingml/2006/main">
             <a:r>
-              <a:rPr lang="en-US" sz="1100"/>
+              <a:rPr lang="en-US" sz="1100">
+                <a:solidFill>
+                  <a:srgbClr val="333333"/>
+                </a:solidFill>
+                <a:latin typeface="Calibri"/>
+                <a:ea typeface="Calibri"/>
+              </a:rPr>
               <a:t>Storage S3 500GB: $11  |  Monitoring (self): $15  |  Networking: $10</a:t>
             </a:r>
           </a:p>
           <a:p xmlns:a="http://schemas.openxmlformats.org/drawingml/2006/main">
             <a:r>
-              <a:rPr lang="en-US" sz="1100"/>
+              <a:rPr lang="en-US" sz="1100">
+                <a:solidFill>
+                  <a:srgbClr val="333333"/>
+                </a:solidFill>
+                <a:latin typeface="Calibri"/>
+                <a:ea typeface="Calibri"/>
+              </a:rPr>
               <a:t>Software (LightGBM/NumPy/Sklearn/Streamlit/community): $0–5</a:t>
             </a:r>
           </a:p>
           <a:p xmlns:a="http://schemas.openxmlformats.org/drawingml/2006/main">
             <a:r>
-              <a:rPr lang="en-US" sz="1100"/>
+              <a:rPr lang="en-US" sz="1100">
+                <a:solidFill>
+                  <a:srgbClr val="333333"/>
+                </a:solidFill>
+                <a:latin typeface="Calibri"/>
+                <a:ea typeface="Calibri"/>
+              </a:rPr>
               <a:t>Data APIs (Binance/Polymarket/Kalshi): $0</a:t>
             </a:r>
           </a:p>
           <a:p xmlns:a="http://schemas.openxmlformats.org/drawingml/2006/main">
             <a:r>
-              <a:rPr lang="en-US" sz="1100"/>
+              <a:rPr lang="en-US" sz="1100">
+                <a:solidFill>
+                  <a:srgbClr val="333333"/>
+                </a:solidFill>
+                <a:latin typeface="Calibri"/>
+                <a:ea typeface="Calibri"/>
+              </a:rPr>
               <a:t>officecli / openpyxl / python-pptx: $0</a:t>
             </a:r>
           </a:p>
           <a:p xmlns:a="http://schemas.openxmlformats.org/drawingml/2006/main">
             <a:r>
-              <a:rPr lang="en-US" sz="1100"/>
+              <a:rPr lang="en-US" sz="1100">
+                <a:solidFill>
+                  <a:srgbClr val="333333"/>
+                </a:solidFill>
+                <a:latin typeface="Calibri"/>
+                <a:ea typeface="Calibri"/>
+              </a:rPr>
               <a:t>Base Shadow: ~$65/mo  |  High Shadow: ~$100/mo  |  Tiny-Live Low: ~$120/mo  |  Tiny-Live High: ~$180/mo (with GPU deferred + Datadog)</a:t>
             </a:r>
           </a:p>
@@ -1094,7 +1412,7 @@
 </file>
 
 <file path=ppt/slides/slide8.xml><?xml version="1.0" encoding="utf-8"?>
-<p:sld xmlns:p="http://schemas.openxmlformats.org/presentationml/2006/main">
+<p:sld xmlns:a="http://schemas.openxmlformats.org/drawingml/2006/main" xmlns:p="http://schemas.openxmlformats.org/presentationml/2006/main">
   <p:cSld>
     <p:spTree>
       <p:nvGrpSpPr>
@@ -1117,16 +1435,21 @@
           <a:prstGeom xmlns:a="http://schemas.openxmlformats.org/drawingml/2006/main" prst="rect">
             <a:avLst/>
           </a:prstGeom>
-        </p:spPr>
-        <p:txBody>
-          <a:bodyPr xmlns:a="http://schemas.openxmlformats.org/drawingml/2006/main"/>
-          <a:lstStyle xmlns:a="http://schemas.openxmlformats.org/drawingml/2006/main"/>
-          <a:p xmlns:a="http://schemas.openxmlformats.org/drawingml/2006/main">
-            <a:r>
-              <a:rPr lang="en-US" sz="2400" b="1">
-                <a:solidFill>
-                  <a:srgbClr val="FFC000"/>
-                </a:solidFill>
+          <a:solidFill>
+            <a:srgbClr val="F4F5F7"/>
+          </a:solidFill>
+        </p:spPr>
+        <p:txBody>
+          <a:bodyPr xmlns:a="http://schemas.openxmlformats.org/drawingml/2006/main"/>
+          <a:lstStyle xmlns:a="http://schemas.openxmlformats.org/drawingml/2006/main"/>
+          <a:p xmlns:a="http://schemas.openxmlformats.org/drawingml/2006/main">
+            <a:r>
+              <a:rPr lang="en-US" sz="2600" b="1">
+                <a:solidFill>
+                  <a:srgbClr val="C5A065"/>
+                </a:solidFill>
+                <a:latin typeface="Calibri"/>
+                <a:ea typeface="Calibri"/>
               </a:rPr>
               <a:t>TIMELINE — P7 ITERATE → P8 PROMOTION</a:t>
             </a:r>
@@ -1147,43 +1470,82 @@
           <a:prstGeom xmlns:a="http://schemas.openxmlformats.org/drawingml/2006/main" prst="rect">
             <a:avLst/>
           </a:prstGeom>
-        </p:spPr>
-        <p:txBody>
-          <a:bodyPr xmlns:a="http://schemas.openxmlformats.org/drawingml/2006/main"/>
-          <a:lstStyle xmlns:a="http://schemas.openxmlformats.org/drawingml/2006/main"/>
-          <a:p xmlns:a="http://schemas.openxmlformats.org/drawingml/2006/main">
-            <a:r>
-              <a:rPr lang="en-US" sz="1100"/>
+          <a:solidFill>
+            <a:srgbClr val="FFFFFF"/>
+          </a:solidFill>
+        </p:spPr>
+        <p:txBody>
+          <a:bodyPr xmlns:a="http://schemas.openxmlformats.org/drawingml/2006/main"/>
+          <a:lstStyle xmlns:a="http://schemas.openxmlformats.org/drawingml/2006/main"/>
+          <a:p xmlns:a="http://schemas.openxmlformats.org/drawingml/2006/main">
+            <a:r>
+              <a:rPr lang="en-US" sz="1100">
+                <a:solidFill>
+                  <a:srgbClr val="333333"/>
+                </a:solidFill>
+                <a:latin typeface="Calibri"/>
+                <a:ea typeface="Calibri"/>
+              </a:rPr>
               <a:t>Week 1–2 — P7.1 Iterate thresholds (sweep 0.30→0.55; turnover reduction; cost-aware sizing)</a:t>
             </a:r>
           </a:p>
           <a:p xmlns:a="http://schemas.openxmlformats.org/drawingml/2006/main">
             <a:r>
-              <a:rPr lang="en-US" sz="1100"/>
+              <a:rPr lang="en-US" sz="1100">
+                <a:solidFill>
+                  <a:srgbClr val="333333"/>
+                </a:solidFill>
+                <a:latin typeface="Calibri"/>
+                <a:ea typeface="Calibri"/>
+              </a:rPr>
               <a:t>Week 3 — P7.2 Cost-aware policy + down-model (p_dn_15 producer or safe 0.0 default)</a:t>
             </a:r>
           </a:p>
           <a:p xmlns:a="http://schemas.openxmlformats.org/drawingml/2006/main">
             <a:r>
-              <a:rPr lang="en-US" sz="1100"/>
+              <a:rPr lang="en-US" sz="1100">
+                <a:solidFill>
+                  <a:srgbClr val="333333"/>
+                </a:solidFill>
+                <a:latin typeface="Calibri"/>
+                <a:ea typeface="Calibri"/>
+              </a:rPr>
               <a:t>Week 4–5 — P7.3 Shadow validation (2+ weeks live match; latency &lt;2s; 0 errors; replay verified)</a:t>
             </a:r>
           </a:p>
           <a:p xmlns:a="http://schemas.openxmlformats.org/drawingml/2006/main">
             <a:r>
-              <a:rPr lang="en-US" sz="1100"/>
+              <a:rPr lang="en-US" sz="1100">
+                <a:solidFill>
+                  <a:srgbClr val="333333"/>
+                </a:solidFill>
+                <a:latin typeface="Calibri"/>
+                <a:ea typeface="Calibri"/>
+              </a:rPr>
               <a:t>Week 6 — P8.1 Paper live (zero real money; JSONL; halt/gate enforced; no dead risk keys)</a:t>
             </a:r>
           </a:p>
           <a:p xmlns:a="http://schemas.openxmlformats.org/drawingml/2006/main">
             <a:r>
-              <a:rPr lang="en-US" sz="1100"/>
+              <a:rPr lang="en-US" sz="1100">
+                <a:solidFill>
+                  <a:srgbClr val="333333"/>
+                </a:solidFill>
+                <a:latin typeface="Calibri"/>
+                <a:ea typeface="Calibri"/>
+              </a:rPr>
               <a:t>Week 7 — P8.2 Tiny-live proposal (this PPT + Excel; cost audit; compliance; investor/user approval)</a:t>
             </a:r>
           </a:p>
           <a:p xmlns:a="http://schemas.openxmlformats.org/drawingml/2006/main">
             <a:r>
-              <a:rPr lang="en-US" sz="1100"/>
+              <a:rPr lang="en-US" sz="1100">
+                <a:solidFill>
+                  <a:srgbClr val="333333"/>
+                </a:solidFill>
+                <a:latin typeface="Calibri"/>
+                <a:ea typeface="Calibri"/>
+              </a:rPr>
               <a:t>Estimated total: 4–7 weeks</a:t>
             </a:r>
           </a:p>
@@ -1195,7 +1557,7 @@
 </file>
 
 <file path=ppt/slides/slide9.xml><?xml version="1.0" encoding="utf-8"?>
-<p:sld xmlns:p="http://schemas.openxmlformats.org/presentationml/2006/main">
+<p:sld xmlns:a="http://schemas.openxmlformats.org/drawingml/2006/main" xmlns:p="http://schemas.openxmlformats.org/presentationml/2006/main">
   <p:cSld>
     <p:spTree>
       <p:nvGrpSpPr>
@@ -1218,16 +1580,21 @@
           <a:prstGeom xmlns:a="http://schemas.openxmlformats.org/drawingml/2006/main" prst="rect">
             <a:avLst/>
           </a:prstGeom>
-        </p:spPr>
-        <p:txBody>
-          <a:bodyPr xmlns:a="http://schemas.openxmlformats.org/drawingml/2006/main"/>
-          <a:lstStyle xmlns:a="http://schemas.openxmlformats.org/drawingml/2006/main"/>
-          <a:p xmlns:a="http://schemas.openxmlformats.org/drawingml/2006/main">
-            <a:r>
-              <a:rPr lang="en-US" sz="2400" b="1">
-                <a:solidFill>
-                  <a:srgbClr val="FFC000"/>
-                </a:solidFill>
+          <a:solidFill>
+            <a:srgbClr val="F4F5F7"/>
+          </a:solidFill>
+        </p:spPr>
+        <p:txBody>
+          <a:bodyPr xmlns:a="http://schemas.openxmlformats.org/drawingml/2006/main"/>
+          <a:lstStyle xmlns:a="http://schemas.openxmlformats.org/drawingml/2006/main"/>
+          <a:p xmlns:a="http://schemas.openxmlformats.org/drawingml/2006/main">
+            <a:r>
+              <a:rPr lang="en-US" sz="2600" b="1">
+                <a:solidFill>
+                  <a:srgbClr val="C5A065"/>
+                </a:solidFill>
+                <a:latin typeface="Calibri"/>
+                <a:ea typeface="Calibri"/>
               </a:rPr>
               <a:t>RISK, GATES &amp; MITIGATION</a:t>
             </a:r>
@@ -1248,31 +1615,58 @@
           <a:prstGeom xmlns:a="http://schemas.openxmlformats.org/drawingml/2006/main" prst="rect">
             <a:avLst/>
           </a:prstGeom>
-        </p:spPr>
-        <p:txBody>
-          <a:bodyPr xmlns:a="http://schemas.openxmlformats.org/drawingml/2006/main"/>
-          <a:lstStyle xmlns:a="http://schemas.openxmlformats.org/drawingml/2006/main"/>
-          <a:p xmlns:a="http://schemas.openxmlformats.org/drawingml/2006/main">
-            <a:r>
-              <a:rPr lang="en-US" sz="1100"/>
+          <a:solidFill>
+            <a:srgbClr val="FFFFFF"/>
+          </a:solidFill>
+        </p:spPr>
+        <p:txBody>
+          <a:bodyPr xmlns:a="http://schemas.openxmlformats.org/drawingml/2006/main"/>
+          <a:lstStyle xmlns:a="http://schemas.openxmlformats.org/drawingml/2006/main"/>
+          <a:p xmlns:a="http://schemas.openxmlformats.org/drawingml/2006/main">
+            <a:r>
+              <a:rPr lang="en-US" sz="1100">
+                <a:solidFill>
+                  <a:srgbClr val="333333"/>
+                </a:solidFill>
+                <a:latin typeface="Calibri"/>
+                <a:ea typeface="Calibri"/>
+              </a:rPr>
               <a:t>P4 Quant: PASS — LightGBM AUC 0.637 / ECE 0.01; baselines A–E validated; no leakage (chronological split + purge/embargo)</a:t>
             </a:r>
           </a:p>
           <a:p xmlns:a="http://schemas.openxmlformats.org/drawingml/2006/main">
             <a:r>
-              <a:rPr lang="en-US" sz="1100"/>
+              <a:rPr lang="en-US" sz="1100">
+                <a:solidFill>
+                  <a:srgbClr val="333333"/>
+                </a:solidFill>
+                <a:latin typeface="Calibri"/>
+                <a:ea typeface="Calibri"/>
+              </a:rPr>
               <a:t>P7 Cost Survival: FAIL — Net negative at high confidence; 2–3× fees deepen linearly; need lower turnover or cost-aware sizing</a:t>
             </a:r>
           </a:p>
           <a:p xmlns:a="http://schemas.openxmlformats.org/drawingml/2006/main">
             <a:r>
-              <a:rPr lang="en-US" sz="1100"/>
+              <a:rPr lang="en-US" sz="1100">
+                <a:solidFill>
+                  <a:srgbClr val="333333"/>
+                </a:solidFill>
+                <a:latin typeface="Calibri"/>
+                <a:ea typeface="Calibri"/>
+              </a:rPr>
               <a:t>P8 Live Match: PASS — Pipeline end-to-end valid; latency 634–1548ms; JSONL hash-verified; consistent with P7 verdict (no entries at p_up~0.13–0.15 vs 0.40 threshold)</a:t>
             </a:r>
           </a:p>
           <a:p xmlns:a="http://schemas.openxmlformats.org/drawingml/2006/main">
             <a:r>
-              <a:rPr lang="en-US" sz="1100"/>
+              <a:rPr lang="en-US" sz="1100">
+                <a:solidFill>
+                  <a:srgbClr val="333333"/>
+                </a:solidFill>
+                <a:latin typeface="Calibri"/>
+                <a:ea typeface="Calibri"/>
+              </a:rPr>
               <a:t>Mitigation: Reduce turnover; threshold grid starting 0.30 (446→189,950 fires); wire costs.json into policy; add p_dn_15 before promotion; enforce all RiskConfig keys (remove dead min_depth/max_open until wired)</a:t>
             </a:r>
           </a:p>

</xml_diff>